<commit_message>
Week 4 Monday: exercises, take-home, Kahoot, reading and trainer files
Adds the guided definition, the three unguided sets (round 3's redesign,
Kalpa's north star with no planted value, the lead-and-lag drill), the lab
set with its Parsons problem, every solution with its Answers line, the
take-home and self-check, the eight-item Kahoot, the study notes under
3,000 words, the one-page cheat sheet, Tuesday's pre-read, the board work,
the interview transcripts, the day sheet with its synced blocks, the war
game run sheet, the role cards, the scorecards, the fallback note, the lab
note and the one-page sources list. The facts file gains eight ids the new
files quote; the data files are unchanged.

Co-Authored-By: Claude Opus 5.5 <noreply@anthropic.com>
Claude-Session: https://claude.ai/code/session_01E6fToBsfuBoCSExpM8sbja
</commit_message>
<xml_diff>
--- a/content/W04/D1/slides/C2_W04_D01_half1_STUDENT.pptx
+++ b/content/W04/D1/slides/C2_W04_D01_half1_STUDENT.pptx
@@ -1361,7 +1361,12 @@
           </a:p>
           <a:p>
             <a:r>
-              <a:t>will show. Then show this full picture and read the two ranges.</a:t>
+              <a:t>will show. Then show this full picture and read the two ranges. Explorer scene M1 draws the same</a:t>
+            </a:r>
+          </a:p>
+          <a:p>
+            <a:r>
+              <a:t>drift with drivers as dots; use it here if it is on the projector.</a:t>
             </a:r>
           </a:p>
           <a:p>
@@ -3586,7 +3591,7 @@
           <a:lstStyle/>
           <a:p>
             <a:r>
-              <a:t>LIVE, 12 minutes, the war game's round 1 (run sheet: trainer/C2_W04_D01_war_game_TRAINER.md).</a:t>
+              <a:t>LIVE, 8 minutes, the war game's round 1 (run sheet: trainer/C2_W04_D01_war_game_TRAINER.md).</a:t>
             </a:r>
           </a:p>
           <a:p>
@@ -3596,7 +3601,7 @@
           </a:p>
           <a:p>
             <a:r>
-              <a:t>four minutes to give one way to game each number, from instinct only, and its scorer holds the</a:t>
+              <a:t>three minutes to give one way to game each number, from instinct only, and its scorer holds the</a:t>
             </a:r>
           </a:p>
           <a:p>

</xml_diff>

<commit_message>
Week 4 Monday: the week map names Kalpa's metric, counts four companies, and prints at a readable size
The map on half1's second slide and the board work names "reorders per member" instead of the
window the lab finds, counts four companies, and carries two short lines a node so its labels print
at 9 points; the closing board runs top-down for the same reason.

Co-Authored-By: Claude Opus 5.5 <noreply@anthropic.com>
Claude-Session: https://claude.ai/code/session_01P7zaoR4dQ5pzBFnsX549JQ
</commit_message>
<xml_diff>
--- a/content/W04/D1/slides/C2_W04_D01_half1_STUDENT.pptx
+++ b/content/W04/D1/slides/C2_W04_D01_half1_STUDENT.pptx
@@ -10520,7 +10520,7 @@
       </p:sp>
       <p:pic>
         <p:nvPicPr>
-          <p:cNvPr id="9" name="mermaid diagram" descr="9dc97cb1fa8c8e3a.png"/>
+          <p:cNvPr id="9" name="mermaid diagram" descr="04c3c64bb20212be.png"/>
           <p:cNvPicPr>
             <a:picLocks noChangeAspect="1"/>
           </p:cNvPicPr>
@@ -10534,8 +10534,8 @@
         </p:blipFill>
         <p:spPr>
           <a:xfrm>
-            <a:off x="3102616" y="1956816"/>
-            <a:ext cx="5986462" cy="1800225"/>
+            <a:off x="3262258" y="1664208"/>
+            <a:ext cx="5667178" cy="2983992"/>
           </a:xfrm>
           <a:prstGeom prst="rect">
             <a:avLst/>
@@ -10550,7 +10550,7 @@
         </p:nvSpPr>
         <p:spPr>
           <a:xfrm>
-            <a:off x="530352" y="3903345"/>
+            <a:off x="530352" y="4693920"/>
             <a:ext cx="11130991" cy="1341120"/>
           </a:xfrm>
           <a:prstGeom prst="roundRect">
@@ -10598,7 +10598,7 @@
         </p:nvSpPr>
         <p:spPr>
           <a:xfrm>
-            <a:off x="676656" y="4031360"/>
+            <a:off x="676656" y="4821936"/>
             <a:ext cx="45720" cy="1085088"/>
           </a:xfrm>
           <a:prstGeom prst="roundRect">
@@ -10644,7 +10644,7 @@
         </p:nvSpPr>
         <p:spPr>
           <a:xfrm>
-            <a:off x="877824" y="4022217"/>
+            <a:off x="877824" y="4812792"/>
             <a:ext cx="10564063" cy="1158240"/>
           </a:xfrm>
           <a:prstGeom prst="rect">
@@ -12241,7 +12241,7 @@
       </p:sp>
       <p:pic>
         <p:nvPicPr>
-          <p:cNvPr id="9" name="mermaid diagram" descr="d772db5e20b1a9dd.png"/>
+          <p:cNvPr id="9" name="mermaid diagram" descr="da66fa08805d999e.png"/>
           <p:cNvPicPr>
             <a:picLocks noChangeAspect="1"/>
           </p:cNvPicPr>
@@ -12255,8 +12255,8 @@
         </p:blipFill>
         <p:spPr>
           <a:xfrm>
-            <a:off x="530352" y="2727681"/>
-            <a:ext cx="4786326" cy="2426764"/>
+            <a:off x="664947" y="1682496"/>
+            <a:ext cx="4517136" cy="4517136"/>
           </a:xfrm>
           <a:prstGeom prst="rect">
             <a:avLst/>
@@ -16995,7 +16995,7 @@
       </p:sp>
       <p:pic>
         <p:nvPicPr>
-          <p:cNvPr id="9" name="mermaid diagram" descr="8470a97220d90526.png"/>
+          <p:cNvPr id="9" name="mermaid diagram" descr="1aa18360ba5e5c02.png"/>
           <p:cNvPicPr>
             <a:picLocks noChangeAspect="1"/>
           </p:cNvPicPr>
@@ -17009,8 +17009,8 @@
         </p:blipFill>
         <p:spPr>
           <a:xfrm>
-            <a:off x="1104184" y="1682496"/>
-            <a:ext cx="9983326" cy="4517136"/>
+            <a:off x="2432035" y="1682496"/>
+            <a:ext cx="7327624" cy="4517136"/>
           </a:xfrm>
           <a:prstGeom prst="rect">
             <a:avLst/>
@@ -18132,7 +18132,7 @@
       </p:sp>
       <p:pic>
         <p:nvPicPr>
-          <p:cNvPr id="9" name="mermaid diagram" descr="49f41a108752e8e1.png"/>
+          <p:cNvPr id="9" name="mermaid diagram" descr="9f70c21823e02228.png"/>
           <p:cNvPicPr>
             <a:picLocks noChangeAspect="1"/>
           </p:cNvPicPr>
@@ -18146,8 +18146,8 @@
         </p:blipFill>
         <p:spPr>
           <a:xfrm>
-            <a:off x="3560514" y="1664208"/>
-            <a:ext cx="5070666" cy="2295144"/>
+            <a:off x="4554938" y="1664208"/>
+            <a:ext cx="3081818" cy="2295144"/>
           </a:xfrm>
           <a:prstGeom prst="rect">
             <a:avLst/>
@@ -22075,7 +22075,7 @@
       </p:sp>
       <p:pic>
         <p:nvPicPr>
-          <p:cNvPr id="9" name="mermaid diagram" descr="7e0f2cc5b29c7c7d.png"/>
+          <p:cNvPr id="9" name="mermaid diagram" descr="0c46bcd733c4c8c8.png"/>
           <p:cNvPicPr>
             <a:picLocks noChangeAspect="1"/>
           </p:cNvPicPr>
@@ -22089,8 +22089,8 @@
         </p:blipFill>
         <p:spPr>
           <a:xfrm>
-            <a:off x="2987822" y="1664208"/>
-            <a:ext cx="6216050" cy="2545080"/>
+            <a:off x="530352" y="2046476"/>
+            <a:ext cx="4786326" cy="3789174"/>
           </a:xfrm>
           <a:prstGeom prst="rect">
             <a:avLst/>
@@ -22105,8 +22105,8 @@
         </p:nvSpPr>
         <p:spPr>
           <a:xfrm>
-            <a:off x="530352" y="4255008"/>
-            <a:ext cx="11130991" cy="807720"/>
+            <a:off x="5761917" y="1956816"/>
+            <a:ext cx="5899425" cy="1341120"/>
           </a:xfrm>
           <a:prstGeom prst="roundRect">
             <a:avLst>
@@ -22153,8 +22153,8 @@
         </p:nvSpPr>
         <p:spPr>
           <a:xfrm>
-            <a:off x="676656" y="4383024"/>
-            <a:ext cx="45720" cy="551688"/>
+            <a:off x="5908221" y="2084832"/>
+            <a:ext cx="45720" cy="1085088"/>
           </a:xfrm>
           <a:prstGeom prst="roundRect">
             <a:avLst>
@@ -22199,8 +22199,8 @@
         </p:nvSpPr>
         <p:spPr>
           <a:xfrm>
-            <a:off x="877824" y="4373880"/>
-            <a:ext cx="10564063" cy="624840"/>
+            <a:off x="6109389" y="2075688"/>
+            <a:ext cx="5332497" cy="1158240"/>
           </a:xfrm>
           <a:prstGeom prst="rect">
             <a:avLst/>
@@ -22242,8 +22242,8 @@
         </p:nvSpPr>
         <p:spPr>
           <a:xfrm>
-            <a:off x="530352" y="5227320"/>
-            <a:ext cx="11130991" cy="807720"/>
+            <a:off x="5761917" y="3462528"/>
+            <a:ext cx="5899425" cy="1341120"/>
           </a:xfrm>
           <a:prstGeom prst="roundRect">
             <a:avLst>
@@ -22290,8 +22290,8 @@
         </p:nvSpPr>
         <p:spPr>
           <a:xfrm>
-            <a:off x="676656" y="5355336"/>
-            <a:ext cx="45720" cy="551688"/>
+            <a:off x="5908221" y="3590544"/>
+            <a:ext cx="45720" cy="1085088"/>
           </a:xfrm>
           <a:prstGeom prst="roundRect">
             <a:avLst>
@@ -22336,8 +22336,8 @@
         </p:nvSpPr>
         <p:spPr>
           <a:xfrm>
-            <a:off x="877824" y="5346192"/>
-            <a:ext cx="10564063" cy="624840"/>
+            <a:off x="6109389" y="3581400"/>
+            <a:ext cx="5332497" cy="1158240"/>
           </a:xfrm>
           <a:prstGeom prst="rect">
             <a:avLst/>
@@ -26744,7 +26744,7 @@
       </p:sp>
       <p:pic>
         <p:nvPicPr>
-          <p:cNvPr id="9" name="mermaid diagram" descr="4ec08a1ec876b01c.png"/>
+          <p:cNvPr id="9" name="mermaid diagram" descr="77feda7222d51a91.png"/>
           <p:cNvPicPr>
             <a:picLocks noChangeAspect="1"/>
           </p:cNvPicPr>
@@ -26758,8 +26758,8 @@
         </p:blipFill>
         <p:spPr>
           <a:xfrm>
-            <a:off x="1688153" y="1925764"/>
-            <a:ext cx="8815387" cy="2543175"/>
+            <a:off x="2999675" y="1664208"/>
+            <a:ext cx="6192344" cy="2983992"/>
           </a:xfrm>
           <a:prstGeom prst="rect">
             <a:avLst/>
@@ -26774,7 +26774,7 @@
         </p:nvSpPr>
         <p:spPr>
           <a:xfrm>
-            <a:off x="530352" y="4615243"/>
+            <a:off x="530352" y="4693920"/>
             <a:ext cx="11130991" cy="1341120"/>
           </a:xfrm>
           <a:prstGeom prst="roundRect">
@@ -26822,7 +26822,7 @@
         </p:nvSpPr>
         <p:spPr>
           <a:xfrm>
-            <a:off x="676656" y="4743259"/>
+            <a:off x="676656" y="4821936"/>
             <a:ext cx="45720" cy="1085088"/>
           </a:xfrm>
           <a:prstGeom prst="roundRect">
@@ -26868,7 +26868,7 @@
         </p:nvSpPr>
         <p:spPr>
           <a:xfrm>
-            <a:off x="877824" y="4734115"/>
+            <a:off x="877824" y="4812792"/>
             <a:ext cx="10564063" cy="1158240"/>
           </a:xfrm>
           <a:prstGeom prst="rect">
@@ -28763,7 +28763,7 @@
       </p:sp>
       <p:pic>
         <p:nvPicPr>
-          <p:cNvPr id="9" name="mermaid diagram" descr="be7c6c0303852b06.png"/>
+          <p:cNvPr id="9" name="mermaid diagram" descr="917e0a52d2801801.png"/>
           <p:cNvPicPr>
             <a:picLocks noChangeAspect="1"/>
           </p:cNvPicPr>
@@ -28777,8 +28777,8 @@
         </p:blipFill>
         <p:spPr>
           <a:xfrm>
-            <a:off x="2998559" y="1664208"/>
-            <a:ext cx="6194576" cy="2979928"/>
+            <a:off x="530352" y="1821033"/>
+            <a:ext cx="4786326" cy="4240060"/>
           </a:xfrm>
           <a:prstGeom prst="rect">
             <a:avLst/>
@@ -28793,20 +28793,25 @@
         </p:nvSpPr>
         <p:spPr>
           <a:xfrm>
-            <a:off x="530352" y="4689856"/>
-            <a:ext cx="11130991" cy="1509775"/>
-          </a:xfrm>
-          <a:prstGeom prst="rect">
-            <a:avLst/>
-          </a:prstGeom>
-          <a:noFill/>
-        </p:spPr>
-        <p:txBody>
-          <a:bodyPr wrap="square" anchor="t" lIns="0" rIns="0" tIns="0" bIns="0">
-            <a:spAutoFit/>
-          </a:bodyPr>
-          <a:lstStyle/>
-          <a:p>
+            <a:off x="5761917" y="1956816"/>
+            <a:ext cx="5899425" cy="2982976"/>
+          </a:xfrm>
+          <a:prstGeom prst="rect">
+            <a:avLst/>
+          </a:prstGeom>
+          <a:noFill/>
+        </p:spPr>
+        <p:txBody>
+          <a:bodyPr wrap="square" anchor="t" lIns="0" rIns="0" tIns="0" bIns="0">
+            <a:spAutoFit/>
+          </a:bodyPr>
+          <a:lstStyle/>
+          <a:p>
+            <a:pPr>
+              <a:spcAft>
+                <a:spcPts val="800"/>
+              </a:spcAft>
+            </a:pPr>
             <a:r>
               <a:rPr sz="1600" b="1" i="0">
                 <a:solidFill>
@@ -32974,7 +32979,7 @@
       </p:sp>
       <p:pic>
         <p:nvPicPr>
-          <p:cNvPr id="9" name="mermaid diagram" descr="40e27b40e15d5162.png"/>
+          <p:cNvPr id="9" name="mermaid diagram" descr="cd9f1854ab09a120.png"/>
           <p:cNvPicPr>
             <a:picLocks noChangeAspect="1"/>
           </p:cNvPicPr>
@@ -32988,8 +32993,8 @@
         </p:blipFill>
         <p:spPr>
           <a:xfrm>
-            <a:off x="1349022" y="1664208"/>
-            <a:ext cx="9493650" cy="3517392"/>
+            <a:off x="2694733" y="1664208"/>
+            <a:ext cx="6802229" cy="3517392"/>
           </a:xfrm>
           <a:prstGeom prst="rect">
             <a:avLst/>
@@ -33648,7 +33653,7 @@
       </p:sp>
       <p:pic>
         <p:nvPicPr>
-          <p:cNvPr id="9" name="mermaid diagram" descr="1c14af4fbb8cd53b.png"/>
+          <p:cNvPr id="9" name="mermaid diagram" descr="6f2eac92cb62179f.png"/>
           <p:cNvPicPr>
             <a:picLocks noChangeAspect="1"/>
           </p:cNvPicPr>
@@ -33662,8 +33667,8 @@
         </p:blipFill>
         <p:spPr>
           <a:xfrm>
-            <a:off x="3375144" y="1664208"/>
-            <a:ext cx="5441405" cy="3808984"/>
+            <a:off x="1325273" y="1682496"/>
+            <a:ext cx="3196483" cy="4517136"/>
           </a:xfrm>
           <a:prstGeom prst="rect">
             <a:avLst/>
@@ -33678,20 +33683,25 @@
         </p:nvSpPr>
         <p:spPr>
           <a:xfrm>
-            <a:off x="530352" y="5518912"/>
-            <a:ext cx="11130991" cy="680720"/>
-          </a:xfrm>
-          <a:prstGeom prst="rect">
-            <a:avLst/>
-          </a:prstGeom>
-          <a:noFill/>
-        </p:spPr>
-        <p:txBody>
-          <a:bodyPr wrap="square" anchor="t" lIns="0" rIns="0" tIns="0" bIns="0">
-            <a:spAutoFit/>
-          </a:bodyPr>
-          <a:lstStyle/>
-          <a:p>
+            <a:off x="5761917" y="1956816"/>
+            <a:ext cx="5899425" cy="1324864"/>
+          </a:xfrm>
+          <a:prstGeom prst="rect">
+            <a:avLst/>
+          </a:prstGeom>
+          <a:noFill/>
+        </p:spPr>
+        <p:txBody>
+          <a:bodyPr wrap="square" anchor="t" lIns="0" rIns="0" tIns="0" bIns="0">
+            <a:spAutoFit/>
+          </a:bodyPr>
+          <a:lstStyle/>
+          <a:p>
+            <a:pPr>
+              <a:spcAft>
+                <a:spcPts val="800"/>
+              </a:spcAft>
+            </a:pPr>
             <a:r>
               <a:rPr sz="1600" b="0" i="0">
                 <a:solidFill>
@@ -38842,7 +38852,7 @@
       </p:sp>
       <p:pic>
         <p:nvPicPr>
-          <p:cNvPr id="9" name="mermaid diagram" descr="4f63bf6b50392052.png"/>
+          <p:cNvPr id="9" name="mermaid diagram" descr="94da0418c15641df.png"/>
           <p:cNvPicPr>
             <a:picLocks noChangeAspect="1"/>
           </p:cNvPicPr>
@@ -38856,8 +38866,8 @@
         </p:blipFill>
         <p:spPr>
           <a:xfrm>
-            <a:off x="530352" y="1956816"/>
-            <a:ext cx="11130991" cy="1770558"/>
+            <a:off x="1219809" y="1664208"/>
+            <a:ext cx="9752076" cy="3250692"/>
           </a:xfrm>
           <a:prstGeom prst="rect">
             <a:avLst/>
@@ -38872,7 +38882,7 @@
         </p:nvSpPr>
         <p:spPr>
           <a:xfrm>
-            <a:off x="530352" y="3873678"/>
+            <a:off x="530352" y="4960620"/>
             <a:ext cx="11130991" cy="1074420"/>
           </a:xfrm>
           <a:prstGeom prst="roundRect">
@@ -38920,7 +38930,7 @@
         </p:nvSpPr>
         <p:spPr>
           <a:xfrm>
-            <a:off x="676656" y="4001694"/>
+            <a:off x="676656" y="5088636"/>
             <a:ext cx="45720" cy="818388"/>
           </a:xfrm>
           <a:prstGeom prst="roundRect">
@@ -38966,7 +38976,7 @@
         </p:nvSpPr>
         <p:spPr>
           <a:xfrm>
-            <a:off x="877824" y="3992550"/>
+            <a:off x="877824" y="5079492"/>
             <a:ext cx="10564063" cy="891540"/>
           </a:xfrm>
           <a:prstGeom prst="rect">

</xml_diff>

<commit_message>
Week 4 Monday: Delhi Metro's slide tells two units from two kinds of day
Co-Authored-By: Claude Opus 5.5 <noreply@anthropic.com>
Claude-Session: https://claude.ai/code/session_01P7zaoR4dQ5pzBFnsX549JQ
</commit_message>
<xml_diff>
--- a/content/W04/D1/slides/C2_W04_D01_half1_STUDENT.pptx
+++ b/content/W04/D1/slides/C2_W04_D01_half1_STUDENT.pptx
@@ -1791,7 +1791,7 @@
           </a:p>
           <a:p>
             <a:r>
-              <a:t>Transition: one crowd, counted three ways.</a:t>
+              <a:t>Transition: one network, counted in two units on two kinds of day.</a:t>
             </a:r>
           </a:p>
         </p:txBody>
@@ -1866,7 +1866,22 @@
           </a:p>
           <a:p>
             <a:r>
-              <a:t>same riders, and offers rose 29 percent on requests that rose 1.8 percent.</a:t>
+              <a:t>same riders, and offers rose 29 percent on requests that rose 1.8 percent. Read the 2018 pair as the</a:t>
+            </a:r>
+          </a:p>
+          <a:p>
+            <a:r>
+              <a:t>unit lesson and the 2026 pair as the day lesson. If asked whether journeys and boardings are one</a:t>
+            </a:r>
+          </a:p>
+          <a:p>
+            <a:r>
+              <a:t>count, say it is our reading of the two records and that DMRC's own definition says a journey counts</a:t>
+            </a:r>
+          </a:p>
+          <a:p>
+            <a:r>
+              <a:t>each line used.</a:t>
             </a:r>
           </a:p>
           <a:p>
@@ -1887,6 +1902,11 @@
           <a:p>
             <a:r>
               <a:t>https://www.republicworld.com/india/delhi-metro-breaks-all-time-record-with-8244-lakh-footfall-as-dtc-strike-sends-rush-soaring-2026-09-18-137241 (checked 12 October 2026)</a:t>
+            </a:r>
+          </a:p>
+          <a:p>
+            <a:r>
+              <a:t>https://www.deccanherald.com/india/delhi/delhi-metro-records-highest-ever-footfall-on-aug-29-2666561 (checked 12 October 2026)</a:t>
             </a:r>
           </a:p>
           <a:p>
@@ -19707,7 +19727,7 @@
                 </a:solidFill>
                 <a:latin typeface="Georgia"/>
               </a:rPr>
-              <a:t>Delhi Metro counts its crowd in three units</a:t>
+              <a:t>Delhi Metro's numbers differ by unit and by day</a:t>
             </a:r>
           </a:p>
         </p:txBody>
@@ -19742,7 +19762,7 @@
                 </a:solidFill>
                 <a:latin typeface="Calibri"/>
               </a:rPr>
-              <a:t>How can one network's crowd give three numbers, none of them wrong?</a:t>
+              <a:t>How can four numbers for one network, from 27 lakh to over 82 lakh, all be right?</a:t>
             </a:r>
           </a:p>
         </p:txBody>
@@ -19756,7 +19776,7 @@
         <p:spPr>
           <a:xfrm>
             <a:off x="530352" y="1956816"/>
-            <a:ext cx="3527450" cy="698500"/>
+            <a:ext cx="2577007" cy="476250"/>
           </a:xfrm>
           <a:prstGeom prst="rect">
             <a:avLst/>
@@ -19771,7 +19791,7 @@
           <a:p>
             <a:pPr algn="l"/>
             <a:r>
-              <a:rPr sz="4400" b="0" i="0">
+              <a:rPr sz="3000" b="0" i="0">
                 <a:solidFill>
                   <a:srgbClr val="5B3FD6"/>
                 </a:solidFill>
@@ -19790,8 +19810,8 @@
         </p:nvSpPr>
         <p:spPr>
           <a:xfrm>
-            <a:off x="530352" y="2691892"/>
-            <a:ext cx="3527450" cy="168656"/>
+            <a:off x="530352" y="2469642"/>
+            <a:ext cx="2577007" cy="168656"/>
           </a:xfrm>
           <a:prstGeom prst="rect">
             <a:avLst/>
@@ -19812,7 +19832,7 @@
                 </a:solidFill>
                 <a:latin typeface="Calibri"/>
               </a:rPr>
-              <a:t>RIDERS A DAY, FEBRUARY 2018</a:t>
+              <a:t>RIDERS A DAY</a:t>
             </a:r>
           </a:p>
         </p:txBody>
@@ -19825,8 +19845,8 @@
         </p:nvSpPr>
         <p:spPr>
           <a:xfrm>
-            <a:off x="530352" y="2893060"/>
-            <a:ext cx="3527450" cy="193421"/>
+            <a:off x="530352" y="2670810"/>
+            <a:ext cx="2577007" cy="350266"/>
           </a:xfrm>
           <a:prstGeom prst="rect">
             <a:avLst/>
@@ -19847,7 +19867,7 @@
                 </a:solidFill>
                 <a:latin typeface="Calibri"/>
               </a:rPr>
-              <a:t>gate count: one entry and one exit, one rider</a:t>
+              <a:t>February 2018: the old count took each rider once</a:t>
             </a:r>
           </a:p>
         </p:txBody>
@@ -19861,7 +19881,7 @@
         <p:spPr>
           <a:xfrm>
             <a:off x="530352" y="3145536"/>
-            <a:ext cx="3527450" cy="10972"/>
+            <a:ext cx="2577007" cy="10972"/>
           </a:xfrm>
           <a:prstGeom prst="rect">
             <a:avLst/>
@@ -19904,8 +19924,8 @@
         </p:nvSpPr>
         <p:spPr>
           <a:xfrm>
-            <a:off x="4332122" y="1956816"/>
-            <a:ext cx="3527450" cy="698500"/>
+            <a:off x="3381679" y="1956816"/>
+            <a:ext cx="2577007" cy="476250"/>
           </a:xfrm>
           <a:prstGeom prst="rect">
             <a:avLst/>
@@ -19920,7 +19940,7 @@
           <a:p>
             <a:pPr algn="l"/>
             <a:r>
-              <a:rPr sz="4400" b="0" i="0">
+              <a:rPr sz="3000" b="0" i="0">
                 <a:solidFill>
                   <a:srgbClr val="5B3FD6"/>
                 </a:solidFill>
@@ -19939,8 +19959,8 @@
         </p:nvSpPr>
         <p:spPr>
           <a:xfrm>
-            <a:off x="4332122" y="2691892"/>
-            <a:ext cx="3527450" cy="168656"/>
+            <a:off x="3381679" y="2469642"/>
+            <a:ext cx="2577007" cy="168656"/>
           </a:xfrm>
           <a:prstGeom prst="rect">
             <a:avLst/>
@@ -19961,7 +19981,7 @@
                 </a:solidFill>
                 <a:latin typeface="Calibri"/>
               </a:rPr>
-              <a:t>LINE UTILISATION, 29 MAY 2018</a:t>
+              <a:t>LINE USES</a:t>
             </a:r>
           </a:p>
         </p:txBody>
@@ -19974,8 +19994,8 @@
         </p:nvSpPr>
         <p:spPr>
           <a:xfrm>
-            <a:off x="4332122" y="2893060"/>
-            <a:ext cx="3527450" cy="193421"/>
+            <a:off x="3381679" y="2670810"/>
+            <a:ext cx="2577007" cy="350266"/>
           </a:xfrm>
           <a:prstGeom prst="rect">
             <a:avLst/>
@@ -19996,7 +20016,7 @@
                 </a:solidFill>
                 <a:latin typeface="Calibri"/>
               </a:rPr>
-              <a:t>every line ridden counts: three lines, three</a:t>
+              <a:t>29 May 2018: a rider on three lines counts three times</a:t>
             </a:r>
           </a:p>
         </p:txBody>
@@ -20009,8 +20029,8 @@
         </p:nvSpPr>
         <p:spPr>
           <a:xfrm>
-            <a:off x="4332122" y="3145536"/>
-            <a:ext cx="3527450" cy="10972"/>
+            <a:off x="3381679" y="3145536"/>
+            <a:ext cx="2577007" cy="10972"/>
           </a:xfrm>
           <a:prstGeom prst="rect">
             <a:avLst/>
@@ -20053,8 +20073,8 @@
         </p:nvSpPr>
         <p:spPr>
           <a:xfrm>
-            <a:off x="8133892" y="1956816"/>
-            <a:ext cx="3527450" cy="698500"/>
+            <a:off x="6233007" y="1956816"/>
+            <a:ext cx="2577007" cy="476250"/>
           </a:xfrm>
           <a:prstGeom prst="rect">
             <a:avLst/>
@@ -20069,13 +20089,13 @@
           <a:p>
             <a:pPr algn="l"/>
             <a:r>
-              <a:rPr sz="4400" b="0" i="0">
+              <a:rPr sz="3000" b="0" i="0">
                 <a:solidFill>
                   <a:srgbClr val="5B3FD6"/>
                 </a:solidFill>
                 <a:latin typeface="Georgia"/>
               </a:rPr>
-              <a:t>82,44,903</a:t>
+              <a:t>64.06 lakh</a:t>
             </a:r>
           </a:p>
         </p:txBody>
@@ -20088,8 +20108,8 @@
         </p:nvSpPr>
         <p:spPr>
           <a:xfrm>
-            <a:off x="8133892" y="2691892"/>
-            <a:ext cx="3527450" cy="168656"/>
+            <a:off x="6233007" y="2469642"/>
+            <a:ext cx="2577007" cy="168656"/>
           </a:xfrm>
           <a:prstGeom prst="rect">
             <a:avLst/>
@@ -20110,7 +20130,7 @@
                 </a:solidFill>
                 <a:latin typeface="Calibri"/>
               </a:rPr>
-              <a:t>BOARDINGS, 17 SEPTEMBER 2026</a:t>
+              <a:t>LINE USES, AVERAGE DAY</a:t>
             </a:r>
           </a:p>
         </p:txBody>
@@ -20123,8 +20143,8 @@
         </p:nvSpPr>
         <p:spPr>
           <a:xfrm>
-            <a:off x="8133892" y="2893060"/>
-            <a:ext cx="3527450" cy="193421"/>
+            <a:off x="6233007" y="2670810"/>
+            <a:ext cx="2577007" cy="193421"/>
           </a:xfrm>
           <a:prstGeom prst="rect">
             <a:avLst/>
@@ -20145,7 +20165,7 @@
                 </a:solidFill>
                 <a:latin typeface="Calibri"/>
               </a:rPr>
-              <a:t>a record day, in a third unit</a:t>
+              <a:t>2026, reported as "journeys"</a:t>
             </a:r>
           </a:p>
         </p:txBody>
@@ -20158,8 +20178,8 @@
         </p:nvSpPr>
         <p:spPr>
           <a:xfrm>
-            <a:off x="8133892" y="3145536"/>
-            <a:ext cx="3527450" cy="10972"/>
+            <a:off x="6233007" y="3145536"/>
+            <a:ext cx="2577007" cy="10972"/>
           </a:xfrm>
           <a:prstGeom prst="rect">
             <a:avLst/>
@@ -20202,8 +20222,157 @@
         </p:nvSpPr>
         <p:spPr>
           <a:xfrm>
+            <a:off x="9084335" y="1956816"/>
+            <a:ext cx="2577007" cy="476250"/>
+          </a:xfrm>
+          <a:prstGeom prst="rect">
+            <a:avLst/>
+          </a:prstGeom>
+          <a:noFill/>
+        </p:spPr>
+        <p:txBody>
+          <a:bodyPr wrap="square" anchor="t" lIns="0" rIns="0" tIns="0" bIns="0">
+            <a:spAutoFit/>
+          </a:bodyPr>
+          <a:lstStyle/>
+          <a:p>
+            <a:pPr algn="l"/>
+            <a:r>
+              <a:rPr sz="3000" b="0" i="0">
+                <a:solidFill>
+                  <a:srgbClr val="5B3FD6"/>
+                </a:solidFill>
+                <a:latin typeface="Georgia"/>
+              </a:rPr>
+              <a:t>82,44,903</a:t>
+            </a:r>
+          </a:p>
+        </p:txBody>
+      </p:sp>
+      <p:sp>
+        <p:nvSpPr>
+          <p:cNvPr id="22" name="TextBox 21"/>
+          <p:cNvSpPr txBox="1"/>
+          <p:nvPr/>
+        </p:nvSpPr>
+        <p:spPr>
+          <a:xfrm>
+            <a:off x="9084335" y="2469642"/>
+            <a:ext cx="2577007" cy="168656"/>
+          </a:xfrm>
+          <a:prstGeom prst="rect">
+            <a:avLst/>
+          </a:prstGeom>
+          <a:noFill/>
+        </p:spPr>
+        <p:txBody>
+          <a:bodyPr wrap="square" anchor="t" lIns="0" rIns="0" tIns="0" bIns="0">
+            <a:spAutoFit/>
+          </a:bodyPr>
+          <a:lstStyle/>
+          <a:p>
+            <a:pPr algn="l"/>
+            <a:r>
+              <a:rPr sz="800" b="1" i="0" spc="250">
+                <a:solidFill>
+                  <a:srgbClr val="1A0F5C"/>
+                </a:solidFill>
+                <a:latin typeface="Calibri"/>
+              </a:rPr>
+              <a:t>LINE USES, RECORD DAY</a:t>
+            </a:r>
+          </a:p>
+        </p:txBody>
+      </p:sp>
+      <p:sp>
+        <p:nvSpPr>
+          <p:cNvPr id="23" name="TextBox 22"/>
+          <p:cNvSpPr txBox="1"/>
+          <p:nvPr/>
+        </p:nvSpPr>
+        <p:spPr>
+          <a:xfrm>
+            <a:off x="9084335" y="2670810"/>
+            <a:ext cx="2577007" cy="350266"/>
+          </a:xfrm>
+          <a:prstGeom prst="rect">
+            <a:avLst/>
+          </a:prstGeom>
+          <a:noFill/>
+        </p:spPr>
+        <p:txBody>
+          <a:bodyPr wrap="square" anchor="t" lIns="0" rIns="0" tIns="0" bIns="0">
+            <a:spAutoFit/>
+          </a:bodyPr>
+          <a:lstStyle/>
+          <a:p>
+            <a:pPr algn="l"/>
+            <a:r>
+              <a:rPr sz="950" b="0" i="0">
+                <a:solidFill>
+                  <a:srgbClr val="6B6690"/>
+                </a:solidFill>
+                <a:latin typeface="Calibri"/>
+              </a:rPr>
+              <a:t>17 September 2026, reported as "boardings"</a:t>
+            </a:r>
+          </a:p>
+        </p:txBody>
+      </p:sp>
+      <p:sp>
+        <p:nvSpPr>
+          <p:cNvPr id="24" name="Rectangle 23"/>
+          <p:cNvSpPr/>
+          <p:nvPr/>
+        </p:nvSpPr>
+        <p:spPr>
+          <a:xfrm>
+            <a:off x="9084335" y="3145536"/>
+            <a:ext cx="2577007" cy="10972"/>
+          </a:xfrm>
+          <a:prstGeom prst="rect">
+            <a:avLst/>
+          </a:prstGeom>
+          <a:solidFill>
+            <a:srgbClr val="E4E1F1"/>
+          </a:solidFill>
+          <a:ln>
+            <a:noFill/>
+          </a:ln>
+          <a:effectLst/>
+        </p:spPr>
+        <p:style>
+          <a:lnRef idx="1">
+            <a:schemeClr val="accent1"/>
+          </a:lnRef>
+          <a:fillRef idx="3">
+            <a:schemeClr val="accent1"/>
+          </a:fillRef>
+          <a:effectRef idx="2">
+            <a:schemeClr val="accent1"/>
+          </a:effectRef>
+          <a:fontRef idx="minor">
+            <a:schemeClr val="lt1"/>
+          </a:fontRef>
+        </p:style>
+        <p:txBody>
+          <a:bodyPr rtlCol="0" anchor="ctr" wrap="square"/>
+          <a:lstStyle/>
+          <a:p>
+            <a:pPr algn="ctr"/>
+          </a:p>
+        </p:txBody>
+      </p:sp>
+      <p:sp>
+        <p:nvSpPr>
+          <p:cNvPr id="25" name="TextBox 24"/>
+          <p:cNvSpPr txBox="1"/>
+          <p:nvPr/>
+        </p:nvSpPr>
+        <p:spPr>
+          <a:xfrm>
             <a:off x="530352" y="3419856"/>
-            <a:ext cx="11130991" cy="1601216"/>
+            <a:ext cx="11130991" cy="2430272"/>
           </a:xfrm>
           <a:prstGeom prst="rect">
             <a:avLst/>
@@ -20228,14 +20397,14 @@
                 </a:solidFill>
                 <a:latin typeface="Calibri"/>
               </a:rPr>
-              <a:t>In 2018 the Delhi Metro Rail Corporation (DMRC) began counting "line utilisation": a rider from Noida City Centre to HUDA City Centre who changes across three lines counts three times, where the gate count counts one rider (PTI, the Press Trust of India). In 2026 the figures arrive as 64.06 lakh average daily "journeys" (The Tribune) and a record day of "boardings" (Republic World), each a different unit again; all checked 12 October 2026. A definition can move a number without moving the crowd.</a:t>
-            </a:r>
-          </a:p>
-        </p:txBody>
-      </p:sp>
-      <p:sp>
-        <p:nvSpPr>
-          <p:cNvPr id="22" name="Oval 21"/>
+              <a:t>In 2018 the Delhi Metro Rail Corporation (DMRC) began counting "line utilisation": a rider who changes across three lines from Noida City Centre to HUDA City Centre counts three times (PTI, the Press Trust of India). So the 2018 pair is one crowd in two units. The 2026 pair is one unit on two kinds of day: an average day (The Tribune) and the record day, when a bus strike sent riders to the Metro (DMRC's post, as Republic World carries it). That "journeys" and "boardings" name the same count is our reading, since the boardings record beat the earlier record of more than 81 lakh "passenger journeys" on 8 August 2025 (The Tribune). All checked 12 October 2026. A definition can move a number without moving the crowd, and so can the choice of day.</a:t>
+            </a:r>
+          </a:p>
+        </p:txBody>
+      </p:sp>
+      <p:sp>
+        <p:nvSpPr>
+          <p:cNvPr id="26" name="Oval 25"/>
           <p:cNvSpPr/>
           <p:nvPr/>
         </p:nvSpPr>
@@ -20279,7 +20448,7 @@
       </p:sp>
       <p:sp>
         <p:nvSpPr>
-          <p:cNvPr id="23" name="TextBox 22"/>
+          <p:cNvPr id="27" name="TextBox 26"/>
           <p:cNvSpPr txBox="1"/>
           <p:nvPr/>
         </p:nvSpPr>
@@ -20314,7 +20483,7 @@
       </p:sp>
       <p:sp>
         <p:nvSpPr>
-          <p:cNvPr id="24" name="Oval 23"/>
+          <p:cNvPr id="28" name="Oval 27"/>
           <p:cNvSpPr/>
           <p:nvPr/>
         </p:nvSpPr>
@@ -20358,7 +20527,7 @@
       </p:sp>
       <p:sp>
         <p:nvSpPr>
-          <p:cNvPr id="25" name="TextBox 24"/>
+          <p:cNvPr id="29" name="TextBox 28"/>
           <p:cNvSpPr txBox="1"/>
           <p:nvPr/>
         </p:nvSpPr>
@@ -20393,7 +20562,7 @@
       </p:sp>
       <p:sp>
         <p:nvSpPr>
-          <p:cNvPr id="26" name="Oval 25"/>
+          <p:cNvPr id="30" name="Oval 29"/>
           <p:cNvSpPr/>
           <p:nvPr/>
         </p:nvSpPr>
@@ -20437,7 +20606,7 @@
       </p:sp>
       <p:sp>
         <p:nvSpPr>
-          <p:cNvPr id="27" name="TextBox 26"/>
+          <p:cNvPr id="31" name="TextBox 30"/>
           <p:cNvSpPr txBox="1"/>
           <p:nvPr/>
         </p:nvSpPr>
@@ -20472,7 +20641,7 @@
       </p:sp>
       <p:sp>
         <p:nvSpPr>
-          <p:cNvPr id="28" name="TextBox 27"/>
+          <p:cNvPr id="32" name="TextBox 31"/>
           <p:cNvSpPr txBox="1"/>
           <p:nvPr/>
         </p:nvSpPr>

</xml_diff>

<commit_message>
Week 4 Monday deck and sheet: E and F keep shorter weeks than the idle tail's average
S9 and the sheet's twelve-row panel say the card's two idle drivers keep shorter weeks than the
tail, which chapter 2's full data shows; the sheet, read after the day, prints the tail's average of
about 39 peak online hours a driver-week. Both rebuilt with mermaid-cli 11.17.0.

Co-Authored-By: Claude Opus 5.5 <noreply@anthropic.com>
Claude-Session: https://claude.ai/code/session_01BiEZwoHQ2Sd5cXLRM9Eshw
</commit_message>
<xml_diff>
--- a/content/W04/D1/slides/C2_W04_D01_half1_STUDENT.pptx
+++ b/content/W04/D1/slides/C2_W04_D01_half1_STUDENT.pptx
@@ -9395,7 +9395,7 @@
         <p:spPr>
           <a:xfrm>
             <a:off x="530352" y="4559808"/>
-            <a:ext cx="11130991" cy="772160"/>
+            <a:ext cx="11130991" cy="1048512"/>
           </a:xfrm>
           <a:prstGeom prst="rect">
             <a:avLst/>
@@ -9420,7 +9420,7 @@
                 </a:solidFill>
                 <a:latin typeface="Calibri"/>
               </a:rPr>
-              <a:t>The before week begins 10 August 2026 and the after week 21 September 2026. These are twelve rows of the case's own driver_weeks; E and F drive in two of the three outer zones, where riders are few.</a:t>
+              <a:t>The before week begins 10 August 2026 and the after week 21 September 2026. These are twelve rows of the case's own driver_weeks; E and F drive in two of the three outer zones, where riders are few. E and F also keep shorter weeks than most drivers who idle like them, which chapter 2's full data shows.</a:t>
             </a:r>
           </a:p>
         </p:txBody>
@@ -10540,7 +10540,7 @@
       </p:sp>
       <p:pic>
         <p:nvPicPr>
-          <p:cNvPr id="9" name="mermaid diagram" descr="04c3c64bb20212be.png"/>
+          <p:cNvPr id="9" name="mermaid diagram" descr="9dc97cb1fa8c8e3a.png"/>
           <p:cNvPicPr>
             <a:picLocks noChangeAspect="1"/>
           </p:cNvPicPr>
@@ -10554,8 +10554,8 @@
         </p:blipFill>
         <p:spPr>
           <a:xfrm>
-            <a:off x="3262258" y="1664208"/>
-            <a:ext cx="5667178" cy="2983992"/>
+            <a:off x="3102616" y="1956816"/>
+            <a:ext cx="5986462" cy="1800225"/>
           </a:xfrm>
           <a:prstGeom prst="rect">
             <a:avLst/>
@@ -10570,7 +10570,7 @@
         </p:nvSpPr>
         <p:spPr>
           <a:xfrm>
-            <a:off x="530352" y="4693920"/>
+            <a:off x="530352" y="3903345"/>
             <a:ext cx="11130991" cy="1341120"/>
           </a:xfrm>
           <a:prstGeom prst="roundRect">
@@ -10618,7 +10618,7 @@
         </p:nvSpPr>
         <p:spPr>
           <a:xfrm>
-            <a:off x="676656" y="4821936"/>
+            <a:off x="676656" y="4031360"/>
             <a:ext cx="45720" cy="1085088"/>
           </a:xfrm>
           <a:prstGeom prst="roundRect">
@@ -10664,7 +10664,7 @@
         </p:nvSpPr>
         <p:spPr>
           <a:xfrm>
-            <a:off x="877824" y="4812792"/>
+            <a:off x="877824" y="4022217"/>
             <a:ext cx="10564063" cy="1158240"/>
           </a:xfrm>
           <a:prstGeom prst="rect">
@@ -12261,7 +12261,7 @@
       </p:sp>
       <p:pic>
         <p:nvPicPr>
-          <p:cNvPr id="9" name="mermaid diagram" descr="da66fa08805d999e.png"/>
+          <p:cNvPr id="9" name="mermaid diagram" descr="d772db5e20b1a9dd.png"/>
           <p:cNvPicPr>
             <a:picLocks noChangeAspect="1"/>
           </p:cNvPicPr>
@@ -12275,8 +12275,8 @@
         </p:blipFill>
         <p:spPr>
           <a:xfrm>
-            <a:off x="664947" y="1682496"/>
-            <a:ext cx="4517136" cy="4517136"/>
+            <a:off x="530352" y="2727681"/>
+            <a:ext cx="4786326" cy="2426764"/>
           </a:xfrm>
           <a:prstGeom prst="rect">
             <a:avLst/>
@@ -17015,7 +17015,7 @@
       </p:sp>
       <p:pic>
         <p:nvPicPr>
-          <p:cNvPr id="9" name="mermaid diagram" descr="1aa18360ba5e5c02.png"/>
+          <p:cNvPr id="9" name="mermaid diagram" descr="a2eda4e502f82a13.png"/>
           <p:cNvPicPr>
             <a:picLocks noChangeAspect="1"/>
           </p:cNvPicPr>
@@ -17029,8 +17029,8 @@
         </p:blipFill>
         <p:spPr>
           <a:xfrm>
-            <a:off x="2432035" y="1682496"/>
-            <a:ext cx="7327624" cy="4517136"/>
+            <a:off x="530352" y="1956816"/>
+            <a:ext cx="11130991" cy="2876434"/>
           </a:xfrm>
           <a:prstGeom prst="rect">
             <a:avLst/>
@@ -18152,7 +18152,7 @@
       </p:sp>
       <p:pic>
         <p:nvPicPr>
-          <p:cNvPr id="9" name="mermaid diagram" descr="9f70c21823e02228.png"/>
+          <p:cNvPr id="9" name="mermaid diagram" descr="49f41a108752e8e1.png"/>
           <p:cNvPicPr>
             <a:picLocks noChangeAspect="1"/>
           </p:cNvPicPr>
@@ -18166,8 +18166,8 @@
         </p:blipFill>
         <p:spPr>
           <a:xfrm>
-            <a:off x="4554938" y="1664208"/>
-            <a:ext cx="3081818" cy="2295144"/>
+            <a:off x="3560514" y="1664208"/>
+            <a:ext cx="5070666" cy="2295144"/>
           </a:xfrm>
           <a:prstGeom prst="rect">
             <a:avLst/>
@@ -22244,7 +22244,7 @@
       </p:sp>
       <p:pic>
         <p:nvPicPr>
-          <p:cNvPr id="9" name="mermaid diagram" descr="0c46bcd733c4c8c8.png"/>
+          <p:cNvPr id="9" name="mermaid diagram" descr="7e0f2cc5b29c7c7d.png"/>
           <p:cNvPicPr>
             <a:picLocks noChangeAspect="1"/>
           </p:cNvPicPr>
@@ -22258,8 +22258,8 @@
         </p:blipFill>
         <p:spPr>
           <a:xfrm>
-            <a:off x="530352" y="2046476"/>
-            <a:ext cx="4786326" cy="3789174"/>
+            <a:off x="2987822" y="1664208"/>
+            <a:ext cx="6216050" cy="2545080"/>
           </a:xfrm>
           <a:prstGeom prst="rect">
             <a:avLst/>
@@ -22274,8 +22274,8 @@
         </p:nvSpPr>
         <p:spPr>
           <a:xfrm>
-            <a:off x="5761917" y="1956816"/>
-            <a:ext cx="5899425" cy="1341120"/>
+            <a:off x="530352" y="4255008"/>
+            <a:ext cx="11130991" cy="807720"/>
           </a:xfrm>
           <a:prstGeom prst="roundRect">
             <a:avLst>
@@ -22322,8 +22322,8 @@
         </p:nvSpPr>
         <p:spPr>
           <a:xfrm>
-            <a:off x="5908221" y="2084832"/>
-            <a:ext cx="45720" cy="1085088"/>
+            <a:off x="676656" y="4383024"/>
+            <a:ext cx="45720" cy="551688"/>
           </a:xfrm>
           <a:prstGeom prst="roundRect">
             <a:avLst>
@@ -22368,8 +22368,8 @@
         </p:nvSpPr>
         <p:spPr>
           <a:xfrm>
-            <a:off x="6109389" y="2075688"/>
-            <a:ext cx="5332497" cy="1158240"/>
+            <a:off x="877824" y="4373880"/>
+            <a:ext cx="10564063" cy="624840"/>
           </a:xfrm>
           <a:prstGeom prst="rect">
             <a:avLst/>
@@ -22411,8 +22411,8 @@
         </p:nvSpPr>
         <p:spPr>
           <a:xfrm>
-            <a:off x="5761917" y="3462528"/>
-            <a:ext cx="5899425" cy="1341120"/>
+            <a:off x="530352" y="5227320"/>
+            <a:ext cx="11130991" cy="807720"/>
           </a:xfrm>
           <a:prstGeom prst="roundRect">
             <a:avLst>
@@ -22459,8 +22459,8 @@
         </p:nvSpPr>
         <p:spPr>
           <a:xfrm>
-            <a:off x="5908221" y="3590544"/>
-            <a:ext cx="45720" cy="1085088"/>
+            <a:off x="676656" y="5355336"/>
+            <a:ext cx="45720" cy="551688"/>
           </a:xfrm>
           <a:prstGeom prst="roundRect">
             <a:avLst>
@@ -22505,8 +22505,8 @@
         </p:nvSpPr>
         <p:spPr>
           <a:xfrm>
-            <a:off x="6109389" y="3581400"/>
-            <a:ext cx="5332497" cy="1158240"/>
+            <a:off x="877824" y="5346192"/>
+            <a:ext cx="10564063" cy="624840"/>
           </a:xfrm>
           <a:prstGeom prst="rect">
             <a:avLst/>
@@ -26913,7 +26913,7 @@
       </p:sp>
       <p:pic>
         <p:nvPicPr>
-          <p:cNvPr id="9" name="mermaid diagram" descr="77feda7222d51a91.png"/>
+          <p:cNvPr id="9" name="mermaid diagram" descr="4ec08a1ec876b01c.png"/>
           <p:cNvPicPr>
             <a:picLocks noChangeAspect="1"/>
           </p:cNvPicPr>
@@ -26927,8 +26927,8 @@
         </p:blipFill>
         <p:spPr>
           <a:xfrm>
-            <a:off x="2999675" y="1664208"/>
-            <a:ext cx="6192344" cy="2983992"/>
+            <a:off x="1688153" y="1925764"/>
+            <a:ext cx="8815387" cy="2543175"/>
           </a:xfrm>
           <a:prstGeom prst="rect">
             <a:avLst/>
@@ -26943,7 +26943,7 @@
         </p:nvSpPr>
         <p:spPr>
           <a:xfrm>
-            <a:off x="530352" y="4693920"/>
+            <a:off x="530352" y="4615243"/>
             <a:ext cx="11130991" cy="1341120"/>
           </a:xfrm>
           <a:prstGeom prst="roundRect">
@@ -26991,7 +26991,7 @@
         </p:nvSpPr>
         <p:spPr>
           <a:xfrm>
-            <a:off x="676656" y="4821936"/>
+            <a:off x="676656" y="4743259"/>
             <a:ext cx="45720" cy="1085088"/>
           </a:xfrm>
           <a:prstGeom prst="roundRect">
@@ -27037,7 +27037,7 @@
         </p:nvSpPr>
         <p:spPr>
           <a:xfrm>
-            <a:off x="877824" y="4812792"/>
+            <a:off x="877824" y="4734115"/>
             <a:ext cx="10564063" cy="1158240"/>
           </a:xfrm>
           <a:prstGeom prst="rect">
@@ -28932,7 +28932,7 @@
       </p:sp>
       <p:pic>
         <p:nvPicPr>
-          <p:cNvPr id="9" name="mermaid diagram" descr="917e0a52d2801801.png"/>
+          <p:cNvPr id="9" name="mermaid diagram" descr="be7c6c0303852b06.png"/>
           <p:cNvPicPr>
             <a:picLocks noChangeAspect="1"/>
           </p:cNvPicPr>
@@ -28946,8 +28946,8 @@
         </p:blipFill>
         <p:spPr>
           <a:xfrm>
-            <a:off x="530352" y="1821033"/>
-            <a:ext cx="4786326" cy="4240060"/>
+            <a:off x="2998559" y="1664208"/>
+            <a:ext cx="6194576" cy="2979928"/>
           </a:xfrm>
           <a:prstGeom prst="rect">
             <a:avLst/>
@@ -28962,25 +28962,20 @@
         </p:nvSpPr>
         <p:spPr>
           <a:xfrm>
-            <a:off x="5761917" y="1956816"/>
-            <a:ext cx="5899425" cy="2982976"/>
-          </a:xfrm>
-          <a:prstGeom prst="rect">
-            <a:avLst/>
-          </a:prstGeom>
-          <a:noFill/>
-        </p:spPr>
-        <p:txBody>
-          <a:bodyPr wrap="square" anchor="t" lIns="0" rIns="0" tIns="0" bIns="0">
-            <a:spAutoFit/>
-          </a:bodyPr>
-          <a:lstStyle/>
-          <a:p>
-            <a:pPr>
-              <a:spcAft>
-                <a:spcPts val="800"/>
-              </a:spcAft>
-            </a:pPr>
+            <a:off x="530352" y="4689856"/>
+            <a:ext cx="11130991" cy="1509775"/>
+          </a:xfrm>
+          <a:prstGeom prst="rect">
+            <a:avLst/>
+          </a:prstGeom>
+          <a:noFill/>
+        </p:spPr>
+        <p:txBody>
+          <a:bodyPr wrap="square" anchor="t" lIns="0" rIns="0" tIns="0" bIns="0">
+            <a:spAutoFit/>
+          </a:bodyPr>
+          <a:lstStyle/>
+          <a:p>
             <a:r>
               <a:rPr sz="1600" b="1" i="0">
                 <a:solidFill>
@@ -33148,7 +33143,7 @@
       </p:sp>
       <p:pic>
         <p:nvPicPr>
-          <p:cNvPr id="9" name="mermaid diagram" descr="cd9f1854ab09a120.png"/>
+          <p:cNvPr id="9" name="mermaid diagram" descr="af37cf4a9e170fba.png"/>
           <p:cNvPicPr>
             <a:picLocks noChangeAspect="1"/>
           </p:cNvPicPr>
@@ -33162,8 +33157,8 @@
         </p:blipFill>
         <p:spPr>
           <a:xfrm>
-            <a:off x="2694733" y="1664208"/>
-            <a:ext cx="6802229" cy="3517392"/>
+            <a:off x="530352" y="1956816"/>
+            <a:ext cx="11130991" cy="2530766"/>
           </a:xfrm>
           <a:prstGeom prst="rect">
             <a:avLst/>
@@ -33178,7 +33173,7 @@
         </p:nvSpPr>
         <p:spPr>
           <a:xfrm>
-            <a:off x="530352" y="5227320"/>
+            <a:off x="530352" y="4633886"/>
             <a:ext cx="11130991" cy="807720"/>
           </a:xfrm>
           <a:prstGeom prst="roundRect">
@@ -33226,7 +33221,7 @@
         </p:nvSpPr>
         <p:spPr>
           <a:xfrm>
-            <a:off x="676656" y="5355336"/>
+            <a:off x="676656" y="4761902"/>
             <a:ext cx="45720" cy="551688"/>
           </a:xfrm>
           <a:prstGeom prst="roundRect">
@@ -33272,7 +33267,7 @@
         </p:nvSpPr>
         <p:spPr>
           <a:xfrm>
-            <a:off x="877824" y="5346192"/>
+            <a:off x="877824" y="4752758"/>
             <a:ext cx="10564063" cy="624840"/>
           </a:xfrm>
           <a:prstGeom prst="rect">
@@ -33822,7 +33817,7 @@
       </p:sp>
       <p:pic>
         <p:nvPicPr>
-          <p:cNvPr id="9" name="mermaid diagram" descr="6f2eac92cb62179f.png"/>
+          <p:cNvPr id="9" name="mermaid diagram" descr="1c14af4fbb8cd53b.png"/>
           <p:cNvPicPr>
             <a:picLocks noChangeAspect="1"/>
           </p:cNvPicPr>
@@ -33836,8 +33831,8 @@
         </p:blipFill>
         <p:spPr>
           <a:xfrm>
-            <a:off x="1325273" y="1682496"/>
-            <a:ext cx="3196483" cy="4517136"/>
+            <a:off x="3375144" y="1664208"/>
+            <a:ext cx="5441405" cy="3808984"/>
           </a:xfrm>
           <a:prstGeom prst="rect">
             <a:avLst/>
@@ -33852,25 +33847,20 @@
         </p:nvSpPr>
         <p:spPr>
           <a:xfrm>
-            <a:off x="5761917" y="1956816"/>
-            <a:ext cx="5899425" cy="1324864"/>
-          </a:xfrm>
-          <a:prstGeom prst="rect">
-            <a:avLst/>
-          </a:prstGeom>
-          <a:noFill/>
-        </p:spPr>
-        <p:txBody>
-          <a:bodyPr wrap="square" anchor="t" lIns="0" rIns="0" tIns="0" bIns="0">
-            <a:spAutoFit/>
-          </a:bodyPr>
-          <a:lstStyle/>
-          <a:p>
-            <a:pPr>
-              <a:spcAft>
-                <a:spcPts val="800"/>
-              </a:spcAft>
-            </a:pPr>
+            <a:off x="530352" y="5518912"/>
+            <a:ext cx="11130991" cy="680720"/>
+          </a:xfrm>
+          <a:prstGeom prst="rect">
+            <a:avLst/>
+          </a:prstGeom>
+          <a:noFill/>
+        </p:spPr>
+        <p:txBody>
+          <a:bodyPr wrap="square" anchor="t" lIns="0" rIns="0" tIns="0" bIns="0">
+            <a:spAutoFit/>
+          </a:bodyPr>
+          <a:lstStyle/>
+          <a:p>
             <a:r>
               <a:rPr sz="1600" b="0" i="0">
                 <a:solidFill>
@@ -39021,7 +39011,7 @@
       </p:sp>
       <p:pic>
         <p:nvPicPr>
-          <p:cNvPr id="9" name="mermaid diagram" descr="94da0418c15641df.png"/>
+          <p:cNvPr id="9" name="mermaid diagram" descr="4f63bf6b50392052.png"/>
           <p:cNvPicPr>
             <a:picLocks noChangeAspect="1"/>
           </p:cNvPicPr>
@@ -39035,8 +39025,8 @@
         </p:blipFill>
         <p:spPr>
           <a:xfrm>
-            <a:off x="1219809" y="1664208"/>
-            <a:ext cx="9752076" cy="3250692"/>
+            <a:off x="530352" y="1956816"/>
+            <a:ext cx="11130991" cy="1770558"/>
           </a:xfrm>
           <a:prstGeom prst="rect">
             <a:avLst/>
@@ -39051,7 +39041,7 @@
         </p:nvSpPr>
         <p:spPr>
           <a:xfrm>
-            <a:off x="530352" y="4960620"/>
+            <a:off x="530352" y="3873678"/>
             <a:ext cx="11130991" cy="1074420"/>
           </a:xfrm>
           <a:prstGeom prst="roundRect">
@@ -39099,7 +39089,7 @@
         </p:nvSpPr>
         <p:spPr>
           <a:xfrm>
-            <a:off x="676656" y="5088636"/>
+            <a:off x="676656" y="4001694"/>
             <a:ext cx="45720" cy="818388"/>
           </a:xfrm>
           <a:prstGeom prst="roundRect">
@@ -39145,7 +39135,7 @@
         </p:nvSpPr>
         <p:spPr>
           <a:xfrm>
-            <a:off x="877824" y="5079492"/>
+            <a:off x="877824" y="3992550"/>
             <a:ext cx="10564063" cy="891540"/>
           </a:xfrm>
           <a:prstGeom prst="rect">

</xml_diff>